<commit_message>
Add held-out benchmark results and realistic figures to slides and README
- reports/heldout*: the synthetic benchmark on 30 frames never used for tuning
  (seeds 1000-1029); results match the tuning frames
- Slides: accuracy slide uses held-out figures, and a new slide on what works
  automatically on the lab's images and what needs the user's help

Co-Authored-By: Claude Opus 5.5 <noreply@anthropic.com>
Claude-Session: https://claude.ai/code/session_019aiWraoGSkXae2B45oFabr
</commit_message>
<xml_diff>
--- a/docs/Diatom_Analyzer_overview.pptx
+++ b/docs/Diatom_Analyzer_overview.pptx
@@ -11,9 +11,10 @@
     <p:sldId id="259" r:id="rId5"/>
     <p:sldId id="260" r:id="rId6"/>
     <p:sldId id="261" r:id="rId7"/>
+    <p:sldId id="262" r:id="rId8"/>
   </p:sldIdLst>
   <p:notesMasterIdLst>
-    <p:notesMasterId r:id="rId8"/>
+    <p:notesMasterId r:id="rId9"/>
   </p:notesMasterIdLst>
   <p:sldSz cx="12192000" cy="6858000"/>
   <p:notesSz cx="6858000" cy="12192000"/>
@@ -859,7 +860,7 @@
           <a:p>
             <a:r>
               <a:rPr lang="en-US" dirty="0"/>
-              <a:t>Figures from reports/synthetic/report.md and reports/synthetic_crowded/report.md; scale figures from the lab's own images.</a:t>
+              <a:t>Held-out reports: reports/heldout and reports/heldout_crowded (seeds 1000-1029). Tuning frames: seeds 0-29.</a:t>
             </a:r>
             <a:endParaRPr lang="en-US" dirty="0"/>
           </a:p>
@@ -947,7 +948,7 @@
           <a:p>
             <a:r>
               <a:rPr lang="en-US" dirty="0"/>
-              <a:t/>
+              <a:t>Figures from running the app's modes over the lab folders. The fix for debris-heavy and dense scenes is a detection model trained on corrected outlines (see How it works).</a:t>
             </a:r>
             <a:endParaRPr lang="en-US" dirty="0"/>
           </a:p>
@@ -971,6 +972,94 @@
             <a:fld id="{F7021451-1387-4CA6-816F-3879F97B5CBC}" type="slidenum">
               <a:rPr lang="en-US"/>
               <a:t>6</a:t>
+            </a:fld>
+            <a:endParaRPr lang="en-US"/>
+          </a:p>
+        </p:txBody>
+      </p:sp>
+    </p:spTree>
+    <p:extLst>
+      <p:ext uri="{BB962C8B-B14F-4D97-AF65-F5344CB8AC3E}">
+        <p14:creationId xmlns:p14="http://schemas.microsoft.com/office/powerpoint/2010/main" val="1024086991"/>
+      </p:ext>
+    </p:extLst>
+  </p:cSld>
+  <p:clrMapOvr>
+    <a:masterClrMapping/>
+  </p:clrMapOvr>
+</p:notes>
+</file>
+
+<file path=ppt/notesSlides/notesSlide7.xml><?xml version="1.0" encoding="utf-8"?>
+<p:notes xmlns:a="http://schemas.openxmlformats.org/drawingml/2006/main" xmlns:r="http://schemas.openxmlformats.org/officeDocument/2006/relationships" xmlns:p="http://schemas.openxmlformats.org/presentationml/2006/main">
+  <p:cSld>
+    <p:spTree>
+      <p:nvGrpSpPr>
+        <p:cNvPr id="1" name=""/>
+        <p:cNvGrpSpPr/>
+        <p:nvPr/>
+      </p:nvGrpSpPr>
+      <p:grpSpPr>
+        <a:xfrm>
+          <a:off x="0" y="0"/>
+          <a:ext cx="0" cy="0"/>
+          <a:chOff x="0" y="0"/>
+          <a:chExt cx="0" cy="0"/>
+        </a:xfrm>
+      </p:grpSpPr>
+      <p:sp>
+        <p:nvSpPr>
+          <p:cNvPr id="2" name="Slide Image Placeholder 1"/>
+          <p:cNvSpPr>
+            <a:spLocks noGrp="1" noRot="1" noChangeAspect="1"/>
+          </p:cNvSpPr>
+          <p:nvPr>
+            <p:ph type="sldImg"/>
+          </p:nvPr>
+        </p:nvSpPr>
+        <p:spPr/>
+      </p:sp>
+      <p:sp>
+        <p:nvSpPr>
+          <p:cNvPr id="3" name="Notes Placeholder 2"/>
+          <p:cNvSpPr>
+            <a:spLocks noGrp="1"/>
+          </p:cNvSpPr>
+          <p:nvPr>
+            <p:ph type="body" idx="1"/>
+          </p:nvPr>
+        </p:nvSpPr>
+        <p:spPr/>
+        <p:txBody>
+          <a:bodyPr/>
+          <a:lstStyle/>
+          <a:p>
+            <a:r>
+              <a:rPr lang="en-US" dirty="0"/>
+              <a:t/>
+            </a:r>
+            <a:endParaRPr lang="en-US" dirty="0"/>
+          </a:p>
+        </p:txBody>
+      </p:sp>
+      <p:sp>
+        <p:nvSpPr>
+          <p:cNvPr id="4" name="Slide Number Placeholder 3"/>
+          <p:cNvSpPr>
+            <a:spLocks noGrp="1"/>
+          </p:cNvSpPr>
+          <p:nvPr>
+            <p:ph type="sldNum" sz="quarter" idx="10"/>
+          </p:nvPr>
+        </p:nvSpPr>
+        <p:spPr/>
+        <p:txBody>
+          <a:bodyPr/>
+          <a:lstStyle/>
+          <a:p>
+            <a:fld id="{F7021451-1387-4CA6-816F-3879F97B5CBC}" type="slidenum">
+              <a:rPr lang="en-US"/>
+              <a:t>7</a:t>
             </a:fld>
             <a:endParaRPr lang="en-US"/>
           </a:p>
@@ -5222,7 +5311,7 @@
                 <a:ea typeface="Calibri" pitchFamily="34" charset="-122"/>
                 <a:cs typeface="Calibri" pitchFamily="34" charset="-120"/>
               </a:rPr>
-              <a:t>the user marks diatoms by dragging tip to tip and the outline is traced for them. Those corrected outlines can train a Cellpose model on the lab's own images (96 % found vs 65 % classically, in our crowded-scene test).</a:t>
+              <a:t>the user marks diatoms by dragging tip to tip and the outline is traced for them. Those corrected outlines can train a Cellpose model on the lab's own images (in a test on 8 unseen crowded frames: 96 % found vs 65 % for the classical method).</a:t>
             </a:r>
             <a:endParaRPr lang="en-US" sz="1400" dirty="0"/>
           </a:p>
@@ -5293,7 +5382,7 @@
                 <a:ea typeface="Arial" pitchFamily="34" charset="-122"/>
                 <a:cs typeface="Arial" pitchFamily="34" charset="-120"/>
               </a:rPr>
-              <a:t>How accurate</a:t>
+              <a:t>How accurate: tested on unseen images</a:t>
             </a:r>
             <a:endParaRPr lang="en-US" sz="3400" dirty="0"/>
           </a:p>
@@ -5332,7 +5421,7 @@
                 <a:ea typeface="Calibri" pitchFamily="34" charset="-122"/>
                 <a:cs typeface="Calibri" pitchFamily="34" charset="-120"/>
               </a:rPr>
-              <a:t>Scale checked on the lab's 123 images; the rest on 30 generated SEM frames with exact answers</a:t>
+              <a:t>Tuned on 30 generated SEM frames, scored on 30 new frames never used for tuning</a:t>
             </a:r>
             <a:endParaRPr lang="en-US" sz="1700" dirty="0"/>
           </a:p>
@@ -5346,7 +5435,7 @@
         </p:nvSpPr>
         <p:spPr>
           <a:xfrm>
-            <a:off x="548640" y="1828800"/>
+            <a:off x="548640" y="1783080"/>
             <a:ext cx="3520440" cy="1783080"/>
           </a:xfrm>
           <a:prstGeom prst="roundRect">
@@ -5373,7 +5462,7 @@
         </p:nvSpPr>
         <p:spPr>
           <a:xfrm>
-            <a:off x="822960" y="2057400"/>
+            <a:off x="822960" y="2011680"/>
             <a:ext cx="3017520" cy="868680"/>
           </a:xfrm>
           <a:prstGeom prst="rect">
@@ -5390,17 +5479,17 @@
               <a:buNone/>
             </a:pPr>
             <a:r>
-              <a:rPr lang="en-US" sz="4400" b="1" dirty="0">
-                <a:solidFill>
-                  <a:srgbClr val="0A7F0A"/>
+              <a:rPr lang="en-US" sz="4000" b="1" dirty="0">
+                <a:solidFill>
+                  <a:srgbClr val="2A78D6"/>
                 </a:solidFill>
                 <a:latin typeface="Arial" pitchFamily="34" charset="0"/>
                 <a:ea typeface="Arial" pitchFamily="34" charset="-122"/>
                 <a:cs typeface="Arial" pitchFamily="34" charset="-120"/>
               </a:rPr>
-              <a:t>123/123</a:t>
-            </a:r>
-            <a:endParaRPr lang="en-US" sz="4400" dirty="0"/>
+              <a:t>142/142</a:t>
+            </a:r>
+            <a:endParaRPr lang="en-US" sz="4000" dirty="0"/>
           </a:p>
         </p:txBody>
       </p:sp>
@@ -5412,8 +5501,8 @@
         </p:nvSpPr>
         <p:spPr>
           <a:xfrm>
-            <a:off x="822960" y="2926080"/>
-            <a:ext cx="3063240" cy="548640"/>
+            <a:off x="822960" y="2880360"/>
+            <a:ext cx="3063240" cy="594360"/>
           </a:xfrm>
           <a:prstGeom prst="rect">
             <a:avLst/>
@@ -5429,7 +5518,7 @@
               <a:buNone/>
             </a:pPr>
             <a:r>
-              <a:rPr lang="en-US" sz="1400" dirty="0">
+              <a:rPr lang="en-US" sz="1350" dirty="0">
                 <a:solidFill>
                   <a:srgbClr val="5B6B82"/>
                 </a:solidFill>
@@ -5437,9 +5526,9 @@
                 <a:ea typeface="Calibri" pitchFamily="34" charset="-122"/>
                 <a:cs typeface="Calibri" pitchFamily="34" charset="-120"/>
               </a:rPr>
-              <a:t>lab images: scale read automatically</a:t>
-            </a:r>
-            <a:endParaRPr lang="en-US" sz="1400" dirty="0"/>
+              <a:t>diatoms found when lying apart, no false detections</a:t>
+            </a:r>
+            <a:endParaRPr lang="en-US" sz="1350" dirty="0"/>
           </a:p>
         </p:txBody>
       </p:sp>
@@ -5451,7 +5540,7 @@
         </p:nvSpPr>
         <p:spPr>
           <a:xfrm>
-            <a:off x="4297680" y="1828800"/>
+            <a:off x="4297680" y="1783080"/>
             <a:ext cx="3520440" cy="1783080"/>
           </a:xfrm>
           <a:prstGeom prst="roundRect">
@@ -5478,7 +5567,7 @@
         </p:nvSpPr>
         <p:spPr>
           <a:xfrm>
-            <a:off x="4572000" y="2057400"/>
+            <a:off x="4572000" y="2011680"/>
             <a:ext cx="3017520" cy="868680"/>
           </a:xfrm>
           <a:prstGeom prst="rect">
@@ -5495,7 +5584,7 @@
               <a:buNone/>
             </a:pPr>
             <a:r>
-              <a:rPr lang="en-US" sz="4400" b="1" dirty="0">
+              <a:rPr lang="en-US" sz="4000" b="1" dirty="0">
                 <a:solidFill>
                   <a:srgbClr val="2A78D6"/>
                 </a:solidFill>
@@ -5503,9 +5592,9 @@
                 <a:ea typeface="Arial" pitchFamily="34" charset="-122"/>
                 <a:cs typeface="Arial" pitchFamily="34" charset="-120"/>
               </a:rPr>
-              <a:t>100 %</a:t>
-            </a:r>
-            <a:endParaRPr lang="en-US" sz="4400" dirty="0"/>
+              <a:t>0.8 %</a:t>
+            </a:r>
+            <a:endParaRPr lang="en-US" sz="4000" dirty="0"/>
           </a:p>
         </p:txBody>
       </p:sp>
@@ -5517,8 +5606,8 @@
         </p:nvSpPr>
         <p:spPr>
           <a:xfrm>
-            <a:off x="4572000" y="2926080"/>
-            <a:ext cx="3063240" cy="548640"/>
+            <a:off x="4572000" y="2880360"/>
+            <a:ext cx="3063240" cy="594360"/>
           </a:xfrm>
           <a:prstGeom prst="rect">
             <a:avLst/>
@@ -5534,7 +5623,7 @@
               <a:buNone/>
             </a:pPr>
             <a:r>
-              <a:rPr lang="en-US" sz="1400" dirty="0">
+              <a:rPr lang="en-US" sz="1350" dirty="0">
                 <a:solidFill>
                   <a:srgbClr val="5B6B82"/>
                 </a:solidFill>
@@ -5542,9 +5631,9 @@
                 <a:ea typeface="Calibri" pitchFamily="34" charset="-122"/>
                 <a:cs typeface="Calibri" pitchFamily="34" charset="-120"/>
               </a:rPr>
-              <a:t>of diatoms found (well separated), no false ones</a:t>
-            </a:r>
-            <a:endParaRPr lang="en-US" sz="1400" dirty="0"/>
+              <a:t>mean length error (scale read from the scale bar)</a:t>
+            </a:r>
+            <a:endParaRPr lang="en-US" sz="1350" dirty="0"/>
           </a:p>
         </p:txBody>
       </p:sp>
@@ -5556,7 +5645,7 @@
         </p:nvSpPr>
         <p:spPr>
           <a:xfrm>
-            <a:off x="8046720" y="1828800"/>
+            <a:off x="8046720" y="1783080"/>
             <a:ext cx="3520440" cy="1783080"/>
           </a:xfrm>
           <a:prstGeom prst="roundRect">
@@ -5583,7 +5672,7 @@
         </p:nvSpPr>
         <p:spPr>
           <a:xfrm>
-            <a:off x="8321040" y="2057400"/>
+            <a:off x="8321040" y="2011680"/>
             <a:ext cx="3017520" cy="868680"/>
           </a:xfrm>
           <a:prstGeom prst="rect">
@@ -5600,17 +5689,17 @@
               <a:buNone/>
             </a:pPr>
             <a:r>
-              <a:rPr lang="en-US" sz="4400" b="1" dirty="0">
-                <a:solidFill>
-                  <a:srgbClr val="2A78D6"/>
+              <a:rPr lang="en-US" sz="4000" b="1" dirty="0">
+                <a:solidFill>
+                  <a:srgbClr val="0A7F0A"/>
                 </a:solidFill>
                 <a:latin typeface="Arial" pitchFamily="34" charset="0"/>
                 <a:ea typeface="Arial" pitchFamily="34" charset="-122"/>
                 <a:cs typeface="Arial" pitchFamily="34" charset="-120"/>
               </a:rPr>
-              <a:t>0.8 %</a:t>
-            </a:r>
-            <a:endParaRPr lang="en-US" sz="4400" dirty="0"/>
+              <a:t>97 %</a:t>
+            </a:r>
+            <a:endParaRPr lang="en-US" sz="4000" dirty="0"/>
           </a:p>
         </p:txBody>
       </p:sp>
@@ -5622,8 +5711,8 @@
         </p:nvSpPr>
         <p:spPr>
           <a:xfrm>
-            <a:off x="8321040" y="2926080"/>
-            <a:ext cx="3063240" cy="548640"/>
+            <a:off x="8321040" y="2880360"/>
+            <a:ext cx="3063240" cy="594360"/>
           </a:xfrm>
           <a:prstGeom prst="rect">
             <a:avLst/>
@@ -5639,7 +5728,7 @@
               <a:buNone/>
             </a:pPr>
             <a:r>
-              <a:rPr lang="en-US" sz="1400" dirty="0">
+              <a:rPr lang="en-US" sz="1350" dirty="0">
                 <a:solidFill>
                   <a:srgbClr val="5B6B82"/>
                 </a:solidFill>
@@ -5647,9 +5736,9 @@
                 <a:ea typeface="Calibri" pitchFamily="34" charset="-122"/>
                 <a:cs typeface="Calibri" pitchFamily="34" charset="-120"/>
               </a:rPr>
-              <a:t>mean length error</a:t>
-            </a:r>
-            <a:endParaRPr lang="en-US" sz="1400" dirty="0"/>
+              <a:t>condition correct: intact 85/85, cracked 28/32, broken 25/25</a:t>
+            </a:r>
+            <a:endParaRPr lang="en-US" sz="1350" dirty="0"/>
           </a:p>
         </p:txBody>
       </p:sp>
@@ -5661,7 +5750,7 @@
         </p:nvSpPr>
         <p:spPr>
           <a:xfrm>
-            <a:off x="548640" y="3840480"/>
+            <a:off x="548640" y="3794760"/>
             <a:ext cx="3520440" cy="1783080"/>
           </a:xfrm>
           <a:prstGeom prst="roundRect">
@@ -5688,7 +5777,7 @@
         </p:nvSpPr>
         <p:spPr>
           <a:xfrm>
-            <a:off x="822960" y="4069080"/>
+            <a:off x="822960" y="4023360"/>
             <a:ext cx="3017520" cy="868680"/>
           </a:xfrm>
           <a:prstGeom prst="rect">
@@ -5705,17 +5794,17 @@
               <a:buNone/>
             </a:pPr>
             <a:r>
-              <a:rPr lang="en-US" sz="4400" b="1" dirty="0">
-                <a:solidFill>
-                  <a:srgbClr val="0A7F0A"/>
+              <a:rPr lang="en-US" sz="4000" b="1" dirty="0">
+                <a:solidFill>
+                  <a:srgbClr val="2A78D6"/>
                 </a:solidFill>
                 <a:latin typeface="Arial" pitchFamily="34" charset="0"/>
                 <a:ea typeface="Arial" pitchFamily="34" charset="-122"/>
                 <a:cs typeface="Arial" pitchFamily="34" charset="-120"/>
               </a:rPr>
-              <a:t>97 %</a:t>
-            </a:r>
-            <a:endParaRPr lang="en-US" sz="4400" dirty="0"/>
+              <a:t>94 → 98 %</a:t>
+            </a:r>
+            <a:endParaRPr lang="en-US" sz="4000" dirty="0"/>
           </a:p>
         </p:txBody>
       </p:sp>
@@ -5727,8 +5816,8 @@
         </p:nvSpPr>
         <p:spPr>
           <a:xfrm>
-            <a:off x="822960" y="4937760"/>
-            <a:ext cx="3063240" cy="548640"/>
+            <a:off x="822960" y="4892040"/>
+            <a:ext cx="3063240" cy="594360"/>
           </a:xfrm>
           <a:prstGeom prst="rect">
             <a:avLst/>
@@ -5744,7 +5833,7 @@
               <a:buNone/>
             </a:pPr>
             <a:r>
-              <a:rPr lang="en-US" sz="1400" dirty="0">
+              <a:rPr lang="en-US" sz="1350" dirty="0">
                 <a:solidFill>
                   <a:srgbClr val="5B6B82"/>
                 </a:solidFill>
@@ -5752,9 +5841,9 @@
                 <a:ea typeface="Calibri" pitchFamily="34" charset="-122"/>
                 <a:cs typeface="Calibri" pitchFamily="34" charset="-120"/>
               </a:rPr>
-              <a:t>damage grades correct</a:t>
-            </a:r>
-            <a:endParaRPr lang="en-US" sz="1400" dirty="0"/>
+              <a:t>species correct with 1 → 5 reference examples each</a:t>
+            </a:r>
+            <a:endParaRPr lang="en-US" sz="1350" dirty="0"/>
           </a:p>
         </p:txBody>
       </p:sp>
@@ -5766,7 +5855,7 @@
         </p:nvSpPr>
         <p:spPr>
           <a:xfrm>
-            <a:off x="4297680" y="3840480"/>
+            <a:off x="4297680" y="3794760"/>
             <a:ext cx="3520440" cy="1783080"/>
           </a:xfrm>
           <a:prstGeom prst="roundRect">
@@ -5793,7 +5882,7 @@
         </p:nvSpPr>
         <p:spPr>
           <a:xfrm>
-            <a:off x="4572000" y="4069080"/>
+            <a:off x="4572000" y="4023360"/>
             <a:ext cx="3017520" cy="868680"/>
           </a:xfrm>
           <a:prstGeom prst="rect">
@@ -5810,7 +5899,7 @@
               <a:buNone/>
             </a:pPr>
             <a:r>
-              <a:rPr lang="en-US" sz="4400" b="1" dirty="0">
+              <a:rPr lang="en-US" sz="4000" b="1" dirty="0">
                 <a:solidFill>
                   <a:srgbClr val="2A78D6"/>
                 </a:solidFill>
@@ -5818,9 +5907,9 @@
                 <a:ea typeface="Arial" pitchFamily="34" charset="-122"/>
                 <a:cs typeface="Arial" pitchFamily="34" charset="-120"/>
               </a:rPr>
-              <a:t>94 %</a:t>
-            </a:r>
-            <a:endParaRPr lang="en-US" sz="4400" dirty="0"/>
+              <a:t>1.7 %</a:t>
+            </a:r>
+            <a:endParaRPr lang="en-US" sz="4000" dirty="0"/>
           </a:p>
         </p:txBody>
       </p:sp>
@@ -5832,8 +5921,8 @@
         </p:nvSpPr>
         <p:spPr>
           <a:xfrm>
-            <a:off x="4572000" y="4937760"/>
-            <a:ext cx="3063240" cy="548640"/>
+            <a:off x="4572000" y="4892040"/>
+            <a:ext cx="3063240" cy="594360"/>
           </a:xfrm>
           <a:prstGeom prst="rect">
             <a:avLst/>
@@ -5849,7 +5938,7 @@
               <a:buNone/>
             </a:pPr>
             <a:r>
-              <a:rPr lang="en-US" sz="1400" dirty="0">
+              <a:rPr lang="en-US" sz="1350" dirty="0">
                 <a:solidFill>
                   <a:srgbClr val="5B6B82"/>
                 </a:solidFill>
@@ -5857,9 +5946,9 @@
                 <a:ea typeface="Calibri" pitchFamily="34" charset="-122"/>
                 <a:cs typeface="Calibri" pitchFamily="34" charset="-120"/>
               </a:rPr>
-              <a:t>species correct with 3 examples each</a:t>
-            </a:r>
-            <a:endParaRPr lang="en-US" sz="1400" dirty="0"/>
+              <a:t>mean error in pore count per diatom</a:t>
+            </a:r>
+            <a:endParaRPr lang="en-US" sz="1350" dirty="0"/>
           </a:p>
         </p:txBody>
       </p:sp>
@@ -5871,7 +5960,7 @@
         </p:nvSpPr>
         <p:spPr>
           <a:xfrm>
-            <a:off x="8046720" y="3840480"/>
+            <a:off x="8046720" y="3794760"/>
             <a:ext cx="3520440" cy="1783080"/>
           </a:xfrm>
           <a:prstGeom prst="roundRect">
@@ -5898,7 +5987,7 @@
         </p:nvSpPr>
         <p:spPr>
           <a:xfrm>
-            <a:off x="8321040" y="4069080"/>
+            <a:off x="8321040" y="4023360"/>
             <a:ext cx="3017520" cy="868680"/>
           </a:xfrm>
           <a:prstGeom prst="rect">
@@ -5915,17 +6004,17 @@
               <a:buNone/>
             </a:pPr>
             <a:r>
-              <a:rPr lang="en-US" sz="4400" b="1" dirty="0">
-                <a:solidFill>
-                  <a:srgbClr val="2A78D6"/>
+              <a:rPr lang="en-US" sz="4000" b="1" dirty="0">
+                <a:solidFill>
+                  <a:srgbClr val="B07800"/>
                 </a:solidFill>
                 <a:latin typeface="Arial" pitchFamily="34" charset="0"/>
                 <a:ea typeface="Arial" pitchFamily="34" charset="-122"/>
                 <a:cs typeface="Arial" pitchFamily="34" charset="-120"/>
               </a:rPr>
-              <a:t>1.6 s</a:t>
-            </a:r>
-            <a:endParaRPr lang="en-US" sz="4400" dirty="0"/>
+              <a:t>71 %</a:t>
+            </a:r>
+            <a:endParaRPr lang="en-US" sz="4000" dirty="0"/>
           </a:p>
         </p:txBody>
       </p:sp>
@@ -5937,8 +6026,8 @@
         </p:nvSpPr>
         <p:spPr>
           <a:xfrm>
-            <a:off x="8321040" y="4937760"/>
-            <a:ext cx="3063240" cy="548640"/>
+            <a:off x="8321040" y="4892040"/>
+            <a:ext cx="3063240" cy="594360"/>
           </a:xfrm>
           <a:prstGeom prst="rect">
             <a:avLst/>
@@ -5954,7 +6043,7 @@
               <a:buNone/>
             </a:pPr>
             <a:r>
-              <a:rPr lang="en-US" sz="1400" dirty="0">
+              <a:rPr lang="en-US" sz="1350" dirty="0">
                 <a:solidFill>
                   <a:srgbClr val="5B6B82"/>
                 </a:solidFill>
@@ -5962,9 +6051,9 @@
                 <a:ea typeface="Calibri" pitchFamily="34" charset="-122"/>
                 <a:cs typeface="Calibri" pitchFamily="34" charset="-120"/>
               </a:rPr>
-              <a:t>per image on one laptop CPU core</a:t>
-            </a:r>
-            <a:endParaRPr lang="en-US" sz="1400" dirty="0"/>
+              <a:t>found in crowded, overlapping scenes (94 % of outlines correct)</a:t>
+            </a:r>
+            <a:endParaRPr lang="en-US" sz="1350" dirty="0"/>
           </a:p>
         </p:txBody>
       </p:sp>
@@ -5993,7 +6082,7 @@
               <a:buNone/>
             </a:pPr>
             <a:r>
-              <a:rPr lang="en-US" sz="1300" i="1" dirty="0">
+              <a:rPr lang="en-US" sz="1250" i="1" dirty="0">
                 <a:solidFill>
                   <a:srgbClr val="5B6B82"/>
                 </a:solidFill>
@@ -6001,9 +6090,9 @@
                 <a:ea typeface="Calibri" pitchFamily="34" charset="-122"/>
                 <a:cs typeface="Calibri" pitchFamily="34" charset="-120"/>
               </a:rPr>
-              <a:t>Harder: crowded, overlapping scenes (75 % found automatically). There the user marks diatoms by hand, or a trained model takes over.</a:t>
-            </a:r>
-            <a:endParaRPr lang="en-US" sz="1300" dirty="0"/>
+              <a:t>Species: reference examples are separate specimen images; scoring uses the diatoms in the test frames (a true train / test split). Generated images have exact answers but are cleaner than real ones.</a:t>
+            </a:r>
+            <a:endParaRPr lang="en-US" sz="1250" dirty="0"/>
           </a:p>
         </p:txBody>
       </p:sp>
@@ -6018,6 +6107,668 @@
 <file path=ppt/slides/slide6.xml><?xml version="1.0" encoding="utf-8"?>
 <p:sld xmlns:a="http://schemas.openxmlformats.org/drawingml/2006/main" xmlns:r="http://schemas.openxmlformats.org/officeDocument/2006/relationships" xmlns:p="http://schemas.openxmlformats.org/presentationml/2006/main">
   <p:cSld name="Slide 6">
+    <p:bg>
+      <p:bgPr>
+        <a:solidFill>
+          <a:srgbClr val="FFFFFF"/>
+        </a:solidFill>
+      </p:bgPr>
+    </p:bg>
+    <p:spTree>
+      <p:nvGrpSpPr>
+        <p:cNvPr id="1" name=""/>
+        <p:cNvGrpSpPr/>
+        <p:nvPr/>
+      </p:nvGrpSpPr>
+      <p:grpSpPr>
+        <a:xfrm>
+          <a:off x="0" y="0"/>
+          <a:ext cx="0" cy="0"/>
+          <a:chOff x="0" y="0"/>
+          <a:chExt cx="0" cy="0"/>
+        </a:xfrm>
+      </p:grpSpPr>
+      <p:sp>
+        <p:nvSpPr>
+          <p:cNvPr id="2" name="Text 0"/>
+          <p:cNvSpPr txBox="1"/>
+          <p:nvPr/>
+        </p:nvSpPr>
+        <p:spPr>
+          <a:xfrm>
+            <a:off x="548640" y="411480"/>
+            <a:ext cx="11064240" cy="731520"/>
+          </a:xfrm>
+          <a:prstGeom prst="rect">
+            <a:avLst/>
+          </a:prstGeom>
+          <a:noFill/>
+          <a:ln/>
+        </p:spPr>
+        <p:txBody>
+          <a:bodyPr wrap="square" lIns="0" tIns="0" rIns="0" bIns="0" rtlCol="0" anchor="ctr"/>
+          <a:lstStyle/>
+          <a:p>
+            <a:pPr indent="0" marL="0">
+              <a:buNone/>
+            </a:pPr>
+            <a:r>
+              <a:rPr lang="en-US" sz="3400" b="1" dirty="0">
+                <a:solidFill>
+                  <a:srgbClr val="10233F"/>
+                </a:solidFill>
+                <a:latin typeface="Arial" pitchFamily="34" charset="0"/>
+                <a:ea typeface="Arial" pitchFamily="34" charset="-122"/>
+                <a:cs typeface="Arial" pitchFamily="34" charset="-120"/>
+              </a:rPr>
+              <a:t>On the lab's own images</a:t>
+            </a:r>
+            <a:endParaRPr lang="en-US" sz="3400" dirty="0"/>
+          </a:p>
+        </p:txBody>
+      </p:sp>
+      <p:sp>
+        <p:nvSpPr>
+          <p:cNvPr id="3" name="Text 1"/>
+          <p:cNvSpPr txBox="1"/>
+          <p:nvPr/>
+        </p:nvSpPr>
+        <p:spPr>
+          <a:xfrm>
+            <a:off x="548640" y="1097280"/>
+            <a:ext cx="11064240" cy="411480"/>
+          </a:xfrm>
+          <a:prstGeom prst="rect">
+            <a:avLst/>
+          </a:prstGeom>
+          <a:noFill/>
+          <a:ln/>
+        </p:spPr>
+        <p:txBody>
+          <a:bodyPr wrap="square" lIns="0" tIns="0" rIns="0" bIns="0" rtlCol="0" anchor="ctr"/>
+          <a:lstStyle/>
+          <a:p>
+            <a:pPr indent="0" marL="0">
+              <a:buNone/>
+            </a:pPr>
+            <a:r>
+              <a:rPr lang="en-US" sz="1700" dirty="0">
+                <a:solidFill>
+                  <a:srgbClr val="5B6B82"/>
+                </a:solidFill>
+                <a:latin typeface="Calibri" pitchFamily="34" charset="0"/>
+                <a:ea typeface="Calibri" pitchFamily="34" charset="-122"/>
+                <a:cs typeface="Calibri" pitchFamily="34" charset="-120"/>
+              </a:rPr>
+              <a:t>123 SEM images from a Phenom desktop SEM and a Hitachi S-4700</a:t>
+            </a:r>
+            <a:endParaRPr lang="en-US" sz="1700" dirty="0"/>
+          </a:p>
+        </p:txBody>
+      </p:sp>
+      <p:sp>
+        <p:nvSpPr>
+          <p:cNvPr id="4" name="Shape 2"/>
+          <p:cNvSpPr/>
+          <p:nvPr/>
+        </p:nvSpPr>
+        <p:spPr>
+          <a:xfrm>
+            <a:off x="548640" y="1783080"/>
+            <a:ext cx="11064240" cy="960120"/>
+          </a:xfrm>
+          <a:prstGeom prst="roundRect">
+            <a:avLst>
+              <a:gd name="adj" fmla="val 13333"/>
+            </a:avLst>
+          </a:prstGeom>
+          <a:solidFill>
+            <a:srgbClr val="EAF2FC"/>
+          </a:solidFill>
+          <a:ln w="12700">
+            <a:solidFill>
+              <a:srgbClr val="EAF2FC"/>
+            </a:solidFill>
+            <a:prstDash val="solid"/>
+          </a:ln>
+        </p:spPr>
+      </p:sp>
+      <p:sp>
+        <p:nvSpPr>
+          <p:cNvPr id="5" name="Text 3"/>
+          <p:cNvSpPr txBox="1"/>
+          <p:nvPr/>
+        </p:nvSpPr>
+        <p:spPr>
+          <a:xfrm>
+            <a:off x="822960" y="1828800"/>
+            <a:ext cx="10607040" cy="868680"/>
+          </a:xfrm>
+          <a:prstGeom prst="rect">
+            <a:avLst/>
+          </a:prstGeom>
+          <a:noFill/>
+          <a:ln/>
+        </p:spPr>
+        <p:txBody>
+          <a:bodyPr wrap="square" lIns="0" tIns="0" rIns="0" bIns="0" rtlCol="0" anchor="ctr"/>
+          <a:lstStyle/>
+          <a:p>
+            <a:pPr indent="0" marL="0">
+              <a:buNone/>
+            </a:pPr>
+            <a:r>
+              <a:rPr lang="en-US" sz="2200" b="1" dirty="0">
+                <a:solidFill>
+                  <a:srgbClr val="10233F"/>
+                </a:solidFill>
+                <a:latin typeface="Calibri" pitchFamily="34" charset="0"/>
+                <a:ea typeface="Calibri" pitchFamily="34" charset="-122"/>
+                <a:cs typeface="Calibri" pitchFamily="34" charset="-120"/>
+              </a:rPr>
+              <a:t>Scale: 123 / 123 </a:t>
+            </a:r>
+            <a:pPr indent="0" marL="0">
+              <a:buNone/>
+            </a:pPr>
+            <a:r>
+              <a:rPr lang="en-US" sz="1500" dirty="0">
+                <a:solidFill>
+                  <a:srgbClr val="5B6B82"/>
+                </a:solidFill>
+                <a:latin typeface="Calibri" pitchFamily="34" charset="0"/>
+                <a:ea typeface="Calibri" pitchFamily="34" charset="-122"/>
+                <a:cs typeface="Calibri" pitchFamily="34" charset="-120"/>
+              </a:rPr>
+              <a:t>read from the microscope's file. Reading the scale bar alone agrees on all 122 images where it can be checked.</a:t>
+            </a:r>
+            <a:endParaRPr lang="en-US" sz="2200" dirty="0"/>
+          </a:p>
+        </p:txBody>
+      </p:sp>
+      <p:sp>
+        <p:nvSpPr>
+          <p:cNvPr id="6" name="Shape 4"/>
+          <p:cNvSpPr/>
+          <p:nvPr/>
+        </p:nvSpPr>
+        <p:spPr>
+          <a:xfrm>
+            <a:off x="548640" y="3017520"/>
+            <a:ext cx="5440680" cy="3291840"/>
+          </a:xfrm>
+          <a:prstGeom prst="roundRect">
+            <a:avLst>
+              <a:gd name="adj" fmla="val 4167"/>
+            </a:avLst>
+          </a:prstGeom>
+          <a:solidFill>
+            <a:srgbClr val="F5F8FC"/>
+          </a:solidFill>
+          <a:ln w="12700">
+            <a:solidFill>
+              <a:srgbClr val="DFE6EF"/>
+            </a:solidFill>
+            <a:prstDash val="solid"/>
+          </a:ln>
+        </p:spPr>
+      </p:sp>
+      <p:sp>
+        <p:nvSpPr>
+          <p:cNvPr id="7" name="Shape 5"/>
+          <p:cNvSpPr/>
+          <p:nvPr/>
+        </p:nvSpPr>
+        <p:spPr>
+          <a:xfrm>
+            <a:off x="822960" y="3246120"/>
+            <a:ext cx="457200" cy="457200"/>
+          </a:xfrm>
+          <a:prstGeom prst="ellipse">
+            <a:avLst/>
+          </a:prstGeom>
+          <a:solidFill>
+            <a:srgbClr val="0CA30C"/>
+          </a:solidFill>
+          <a:ln w="12700">
+            <a:solidFill>
+              <a:srgbClr val="0CA30C"/>
+            </a:solidFill>
+            <a:prstDash val="solid"/>
+          </a:ln>
+        </p:spPr>
+      </p:sp>
+      <p:sp>
+        <p:nvSpPr>
+          <p:cNvPr id="8" name="Text 6"/>
+          <p:cNvSpPr txBox="1"/>
+          <p:nvPr/>
+        </p:nvSpPr>
+        <p:spPr>
+          <a:xfrm>
+            <a:off x="822960" y="3246120"/>
+            <a:ext cx="457200" cy="457200"/>
+          </a:xfrm>
+          <a:prstGeom prst="rect">
+            <a:avLst/>
+          </a:prstGeom>
+          <a:noFill/>
+          <a:ln/>
+        </p:spPr>
+        <p:txBody>
+          <a:bodyPr wrap="square" lIns="0" tIns="0" rIns="0" bIns="0" rtlCol="0" anchor="ctr"/>
+          <a:lstStyle/>
+          <a:p>
+            <a:pPr algn="ctr" indent="0" marL="0">
+              <a:buNone/>
+            </a:pPr>
+            <a:r>
+              <a:rPr lang="en-US" sz="1600" b="1" dirty="0">
+                <a:solidFill>
+                  <a:srgbClr val="FFFFFF"/>
+                </a:solidFill>
+                <a:latin typeface="Arial" pitchFamily="34" charset="0"/>
+                <a:ea typeface="Arial" pitchFamily="34" charset="-122"/>
+                <a:cs typeface="Arial" pitchFamily="34" charset="-120"/>
+              </a:rPr>
+              <a:t>✓</a:t>
+            </a:r>
+            <a:endParaRPr lang="en-US" sz="1600" dirty="0"/>
+          </a:p>
+        </p:txBody>
+      </p:sp>
+      <p:sp>
+        <p:nvSpPr>
+          <p:cNvPr id="9" name="Text 7"/>
+          <p:cNvSpPr txBox="1"/>
+          <p:nvPr/>
+        </p:nvSpPr>
+        <p:spPr>
+          <a:xfrm>
+            <a:off x="1417320" y="3246120"/>
+            <a:ext cx="4389120" cy="457200"/>
+          </a:xfrm>
+          <a:prstGeom prst="rect">
+            <a:avLst/>
+          </a:prstGeom>
+          <a:noFill/>
+          <a:ln/>
+        </p:spPr>
+        <p:txBody>
+          <a:bodyPr wrap="square" lIns="0" tIns="0" rIns="0" bIns="0" rtlCol="0" anchor="ctr"/>
+          <a:lstStyle/>
+          <a:p>
+            <a:pPr indent="0" marL="0">
+              <a:buNone/>
+            </a:pPr>
+            <a:r>
+              <a:rPr lang="en-US" sz="1800" b="1" dirty="0">
+                <a:solidFill>
+                  <a:srgbClr val="10233F"/>
+                </a:solidFill>
+                <a:latin typeface="Arial" pitchFamily="34" charset="0"/>
+                <a:ea typeface="Arial" pitchFamily="34" charset="-122"/>
+                <a:cs typeface="Arial" pitchFamily="34" charset="-120"/>
+              </a:rPr>
+              <a:t>Works automatically</a:t>
+            </a:r>
+            <a:endParaRPr lang="en-US" sz="1800" dirty="0"/>
+          </a:p>
+        </p:txBody>
+      </p:sp>
+      <p:sp>
+        <p:nvSpPr>
+          <p:cNvPr id="10" name="Text 8"/>
+          <p:cNvSpPr txBox="1"/>
+          <p:nvPr/>
+        </p:nvSpPr>
+        <p:spPr>
+          <a:xfrm>
+            <a:off x="822960" y="3886200"/>
+            <a:ext cx="4937760" cy="2286000"/>
+          </a:xfrm>
+          <a:prstGeom prst="rect">
+            <a:avLst/>
+          </a:prstGeom>
+          <a:noFill/>
+          <a:ln/>
+        </p:spPr>
+        <p:txBody>
+          <a:bodyPr wrap="square" lIns="0" tIns="0" rIns="0" bIns="0" rtlCol="0" anchor="t"/>
+          <a:lstStyle/>
+          <a:p>
+            <a:pPr marL="342900" indent="-342900">
+              <a:spcAft>
+                <a:spcPts val="600"/>
+              </a:spcAft>
+              <a:buSzPct val="100000"/>
+              <a:buChar char="•"/>
+            </a:pPr>
+            <a:r>
+              <a:rPr lang="en-US" sz="1400" dirty="0">
+                <a:solidFill>
+                  <a:srgbClr val="5B6B82"/>
+                </a:solidFill>
+                <a:latin typeface="Calibri" pitchFamily="34" charset="0"/>
+                <a:ea typeface="Calibri" pitchFamily="34" charset="-122"/>
+                <a:cs typeface="Calibri" pitchFamily="34" charset="-120"/>
+              </a:rPr>
+              <a:t>Diatoms on a clean background (Richmond pennates, 1-10 per image)</a:t>
+            </a:r>
+            <a:endParaRPr lang="en-US" sz="1400" dirty="0"/>
+          </a:p>
+          <a:p>
+            <a:pPr marL="342900" indent="-342900">
+              <a:spcAft>
+                <a:spcPts val="600"/>
+              </a:spcAft>
+              <a:buSzPct val="100000"/>
+              <a:buChar char="•"/>
+            </a:pPr>
+            <a:r>
+              <a:rPr lang="en-US" sz="1400" dirty="0">
+                <a:solidFill>
+                  <a:srgbClr val="5B6B82"/>
+                </a:solidFill>
+                <a:latin typeface="Calibri" pitchFamily="34" charset="0"/>
+                <a:ea typeface="Calibri" pitchFamily="34" charset="-122"/>
+                <a:cs typeface="Calibri" pitchFamily="34" charset="-120"/>
+              </a:rPr>
+              <a:t>Packed Thalassiosira cultures: 90-120 valves per image in round-cell mode</a:t>
+            </a:r>
+            <a:endParaRPr lang="en-US" sz="1400" dirty="0"/>
+          </a:p>
+          <a:p>
+            <a:pPr marL="342900" indent="-342900">
+              <a:spcAft>
+                <a:spcPts val="600"/>
+              </a:spcAft>
+              <a:buSzPct val="100000"/>
+              <a:buChar char="•"/>
+            </a:pPr>
+            <a:r>
+              <a:rPr lang="en-US" sz="1400" dirty="0">
+                <a:solidFill>
+                  <a:srgbClr val="5B6B82"/>
+                </a:solidFill>
+                <a:latin typeface="Calibri" pitchFamily="34" charset="0"/>
+                <a:ea typeface="Calibri" pitchFamily="34" charset="-122"/>
+                <a:cs typeface="Calibri" pitchFamily="34" charset="-120"/>
+              </a:rPr>
+              <a:t>Hitachi images at 3,000×: 30-45 valves each, scale from the .txt file</a:t>
+            </a:r>
+            <a:endParaRPr lang="en-US" sz="1400" dirty="0"/>
+          </a:p>
+          <a:p>
+            <a:pPr marL="342900" indent="-342900">
+              <a:spcAft>
+                <a:spcPts val="600"/>
+              </a:spcAft>
+              <a:buSzPct val="100000"/>
+              <a:buChar char="•"/>
+            </a:pPr>
+            <a:r>
+              <a:rPr lang="en-US" sz="1400" dirty="0">
+                <a:solidFill>
+                  <a:srgbClr val="5B6B82"/>
+                </a:solidFill>
+                <a:latin typeface="Calibri" pitchFamily="34" charset="0"/>
+                <a:ea typeface="Calibri" pitchFamily="34" charset="-122"/>
+                <a:cs typeface="Calibri" pitchFamily="34" charset="-120"/>
+              </a:rPr>
+              <a:t>1-20 s per image on a laptop</a:t>
+            </a:r>
+            <a:endParaRPr lang="en-US" sz="1400" dirty="0"/>
+          </a:p>
+        </p:txBody>
+      </p:sp>
+      <p:sp>
+        <p:nvSpPr>
+          <p:cNvPr id="11" name="Shape 9"/>
+          <p:cNvSpPr/>
+          <p:nvPr/>
+        </p:nvSpPr>
+        <p:spPr>
+          <a:xfrm>
+            <a:off x="6172200" y="3017520"/>
+            <a:ext cx="5440680" cy="3291840"/>
+          </a:xfrm>
+          <a:prstGeom prst="roundRect">
+            <a:avLst>
+              <a:gd name="adj" fmla="val 4167"/>
+            </a:avLst>
+          </a:prstGeom>
+          <a:solidFill>
+            <a:srgbClr val="F5F8FC"/>
+          </a:solidFill>
+          <a:ln w="12700">
+            <a:solidFill>
+              <a:srgbClr val="DFE6EF"/>
+            </a:solidFill>
+            <a:prstDash val="solid"/>
+          </a:ln>
+        </p:spPr>
+      </p:sp>
+      <p:sp>
+        <p:nvSpPr>
+          <p:cNvPr id="12" name="Shape 10"/>
+          <p:cNvSpPr/>
+          <p:nvPr/>
+        </p:nvSpPr>
+        <p:spPr>
+          <a:xfrm>
+            <a:off x="6446520" y="3246120"/>
+            <a:ext cx="457200" cy="457200"/>
+          </a:xfrm>
+          <a:prstGeom prst="ellipse">
+            <a:avLst/>
+          </a:prstGeom>
+          <a:solidFill>
+            <a:srgbClr val="FAB219"/>
+          </a:solidFill>
+          <a:ln w="12700">
+            <a:solidFill>
+              <a:srgbClr val="FAB219"/>
+            </a:solidFill>
+            <a:prstDash val="solid"/>
+          </a:ln>
+        </p:spPr>
+      </p:sp>
+      <p:sp>
+        <p:nvSpPr>
+          <p:cNvPr id="13" name="Text 11"/>
+          <p:cNvSpPr txBox="1"/>
+          <p:nvPr/>
+        </p:nvSpPr>
+        <p:spPr>
+          <a:xfrm>
+            <a:off x="6446520" y="3246120"/>
+            <a:ext cx="457200" cy="457200"/>
+          </a:xfrm>
+          <a:prstGeom prst="rect">
+            <a:avLst/>
+          </a:prstGeom>
+          <a:noFill/>
+          <a:ln/>
+        </p:spPr>
+        <p:txBody>
+          <a:bodyPr wrap="square" lIns="0" tIns="0" rIns="0" bIns="0" rtlCol="0" anchor="ctr"/>
+          <a:lstStyle/>
+          <a:p>
+            <a:pPr algn="ctr" indent="0" marL="0">
+              <a:buNone/>
+            </a:pPr>
+            <a:r>
+              <a:rPr lang="en-US" sz="1600" b="1" dirty="0">
+                <a:solidFill>
+                  <a:srgbClr val="FFFFFF"/>
+                </a:solidFill>
+                <a:latin typeface="Arial" pitchFamily="34" charset="0"/>
+                <a:ea typeface="Arial" pitchFamily="34" charset="-122"/>
+                <a:cs typeface="Arial" pitchFamily="34" charset="-120"/>
+              </a:rPr>
+              <a:t>!</a:t>
+            </a:r>
+            <a:endParaRPr lang="en-US" sz="1600" dirty="0"/>
+          </a:p>
+        </p:txBody>
+      </p:sp>
+      <p:sp>
+        <p:nvSpPr>
+          <p:cNvPr id="14" name="Text 12"/>
+          <p:cNvSpPr txBox="1"/>
+          <p:nvPr/>
+        </p:nvSpPr>
+        <p:spPr>
+          <a:xfrm>
+            <a:off x="7040880" y="3246120"/>
+            <a:ext cx="4389120" cy="457200"/>
+          </a:xfrm>
+          <a:prstGeom prst="rect">
+            <a:avLst/>
+          </a:prstGeom>
+          <a:noFill/>
+          <a:ln/>
+        </p:spPr>
+        <p:txBody>
+          <a:bodyPr wrap="square" lIns="0" tIns="0" rIns="0" bIns="0" rtlCol="0" anchor="ctr"/>
+          <a:lstStyle/>
+          <a:p>
+            <a:pPr indent="0" marL="0">
+              <a:buNone/>
+            </a:pPr>
+            <a:r>
+              <a:rPr lang="en-US" sz="1800" b="1" dirty="0">
+                <a:solidFill>
+                  <a:srgbClr val="10233F"/>
+                </a:solidFill>
+                <a:latin typeface="Arial" pitchFamily="34" charset="0"/>
+                <a:ea typeface="Arial" pitchFamily="34" charset="-122"/>
+                <a:cs typeface="Arial" pitchFamily="34" charset="-120"/>
+              </a:rPr>
+              <a:t>Needs the user's help</a:t>
+            </a:r>
+            <a:endParaRPr lang="en-US" sz="1800" dirty="0"/>
+          </a:p>
+        </p:txBody>
+      </p:sp>
+      <p:sp>
+        <p:nvSpPr>
+          <p:cNvPr id="15" name="Text 13"/>
+          <p:cNvSpPr txBox="1"/>
+          <p:nvPr/>
+        </p:nvSpPr>
+        <p:spPr>
+          <a:xfrm>
+            <a:off x="6446520" y="3886200"/>
+            <a:ext cx="4937760" cy="2286000"/>
+          </a:xfrm>
+          <a:prstGeom prst="rect">
+            <a:avLst/>
+          </a:prstGeom>
+          <a:noFill/>
+          <a:ln/>
+        </p:spPr>
+        <p:txBody>
+          <a:bodyPr wrap="square" lIns="0" tIns="0" rIns="0" bIns="0" rtlCol="0" anchor="t"/>
+          <a:lstStyle/>
+          <a:p>
+            <a:pPr marL="342900" indent="-342900">
+              <a:spcAft>
+                <a:spcPts val="600"/>
+              </a:spcAft>
+              <a:buSzPct val="100000"/>
+              <a:buChar char="•"/>
+            </a:pPr>
+            <a:r>
+              <a:rPr lang="en-US" sz="1400" dirty="0">
+                <a:solidFill>
+                  <a:srgbClr val="5B6B82"/>
+                </a:solidFill>
+                <a:latin typeface="Calibri" pitchFamily="34" charset="0"/>
+                <a:ea typeface="Calibri" pitchFamily="34" charset="-122"/>
+                <a:cs typeface="Calibri" pitchFamily="34" charset="-120"/>
+              </a:rPr>
+              <a:t>Debris-heavy diatomite: mineral grains get outlined; remove them or mark diatoms by hand</a:t>
+            </a:r>
+            <a:endParaRPr lang="en-US" sz="1400" dirty="0"/>
+          </a:p>
+          <a:p>
+            <a:pPr marL="342900" indent="-342900">
+              <a:spcAft>
+                <a:spcPts val="600"/>
+              </a:spcAft>
+              <a:buSzPct val="100000"/>
+              <a:buChar char="•"/>
+            </a:pPr>
+            <a:r>
+              <a:rPr lang="en-US" sz="1400" dirty="0">
+                <a:solidFill>
+                  <a:srgbClr val="5B6B82"/>
+                </a:solidFill>
+                <a:latin typeface="Calibri" pitchFamily="34" charset="0"/>
+                <a:ea typeface="Calibri" pitchFamily="34" charset="-122"/>
+                <a:cs typeface="Calibri" pitchFamily="34" charset="-120"/>
+              </a:rPr>
+              <a:t>Dense Didymosphenia fields: mark each cell by dragging tip to tip, then grade it</a:t>
+            </a:r>
+            <a:endParaRPr lang="en-US" sz="1400" dirty="0"/>
+          </a:p>
+          <a:p>
+            <a:pPr marL="342900" indent="-342900">
+              <a:spcAft>
+                <a:spcPts val="600"/>
+              </a:spcAft>
+              <a:buSzPct val="100000"/>
+              <a:buChar char="•"/>
+            </a:pPr>
+            <a:r>
+              <a:rPr lang="en-US" sz="1400" dirty="0">
+                <a:solidFill>
+                  <a:srgbClr val="5B6B82"/>
+                </a:solidFill>
+                <a:latin typeface="Calibri" pitchFamily="34" charset="0"/>
+                <a:ea typeface="Calibri" pitchFamily="34" charset="-122"/>
+                <a:cs typeface="Calibri" pitchFamily="34" charset="-120"/>
+              </a:rPr>
+              <a:t>Close-ups of one or two cells: round-cell mode can add false circles</a:t>
+            </a:r>
+            <a:endParaRPr lang="en-US" sz="1400" dirty="0"/>
+          </a:p>
+          <a:p>
+            <a:pPr marL="342900" indent="-342900">
+              <a:spcAft>
+                <a:spcPts val="600"/>
+              </a:spcAft>
+              <a:buSzPct val="100000"/>
+              <a:buChar char="•"/>
+            </a:pPr>
+            <a:r>
+              <a:rPr lang="en-US" sz="1400" dirty="0">
+                <a:solidFill>
+                  <a:srgbClr val="5B6B82"/>
+                </a:solidFill>
+                <a:latin typeface="Calibri" pitchFamily="34" charset="0"/>
+                <a:ea typeface="Calibri" pitchFamily="34" charset="-122"/>
+                <a:cs typeface="Calibri" pitchFamily="34" charset="-120"/>
+              </a:rPr>
+              <a:t>Real-image counting accuracy not yet measured: needs 10-20 hand-labelled images</a:t>
+            </a:r>
+            <a:endParaRPr lang="en-US" sz="1400" dirty="0"/>
+          </a:p>
+        </p:txBody>
+      </p:sp>
+    </p:spTree>
+  </p:cSld>
+  <p:clrMapOvr>
+    <a:masterClrMapping/>
+  </p:clrMapOvr>
+</p:sld>
+</file>
+
+<file path=ppt/slides/slide7.xml><?xml version="1.0" encoding="utf-8"?>
+<p:sld xmlns:a="http://schemas.openxmlformats.org/drawingml/2006/main" xmlns:r="http://schemas.openxmlformats.org/officeDocument/2006/relationships" xmlns:p="http://schemas.openxmlformats.org/presentationml/2006/main">
+  <p:cSld name="Slide 7">
     <p:bg>
       <p:bgPr>
         <a:solidFill>

</xml_diff>